<commit_message>
Add sensitivity analysis; fix rocket tables and Figure 5 units
- Add scripts/sensitivity.py and results/sensitivity.csv (one-at-a-time
  sensitivity of the headline results); Monte Carlo now reads the model
  directly; update model inputs, results, paper text and figures.
- Rocket tables (Figure 1): add missing solid propellant to Atlas V, LVM3
  and Vulcan Centaur fuel types; give Falcon-Heavy and Vulcan Centaur the
  same column width; regenerate tables and update a_rockets.pptx with the
  tables aligned and each rocket centred over its column.
- Figure 5: add units to the propellant axis, label payload capacity in
  tonnes and stop the Starship dry-mass label being clipped.
- oracle_model.py: read reference files with Path.open so --check runs on
  Python 3.12.

Co-Authored-By: Claude Opus 5.5 <noreply@anthropic.com>
</commit_message>
<xml_diff>
--- a/vis/figures/a_rockets.pptx
+++ b/vis/figures/a_rockets.pptx
@@ -2993,13 +2993,13 @@
               </a:ext>
             </a:extLst>
           </a:blip>
-          <a:srcRect r="5783"/>
+          <a:srcRect l="3472" r="3472"/>
           <a:stretch/>
         </p:blipFill>
         <p:spPr>
           <a:xfrm>
-            <a:off x="653170" y="7015666"/>
-            <a:ext cx="7441661" cy="1579673"/>
+            <a:off x="897020" y="7015666"/>
+            <a:ext cx="7349959" cy="1579673"/>
           </a:xfrm>
           <a:prstGeom prst="rect">
             <a:avLst/>
@@ -3028,13 +3028,13 @@
               </a:ext>
             </a:extLst>
           </a:blip>
-          <a:srcRect r="5783"/>
+          <a:srcRect l="3472" r="3472"/>
           <a:stretch/>
         </p:blipFill>
         <p:spPr>
           <a:xfrm>
-            <a:off x="653171" y="3110487"/>
-            <a:ext cx="7441660" cy="1579672"/>
+            <a:off x="897020" y="3110487"/>
+            <a:ext cx="7349959" cy="1579672"/>
           </a:xfrm>
           <a:prstGeom prst="rect">
             <a:avLst/>
@@ -3062,7 +3062,7 @@
         </p:blipFill>
         <p:spPr>
           <a:xfrm flipH="1">
-            <a:off x="2028447" y="4702192"/>
+            <a:off x="2139460" y="4702192"/>
             <a:ext cx="735374" cy="2452746"/>
           </a:xfrm>
           <a:prstGeom prst="rect">
@@ -3092,7 +3092,7 @@
         </p:blipFill>
         <p:spPr>
           <a:xfrm>
-            <a:off x="4307173" y="4705515"/>
+            <a:off x="4367666" y="4705515"/>
             <a:ext cx="396077" cy="2449423"/>
           </a:xfrm>
           <a:prstGeom prst="rect">
@@ -3121,7 +3121,7 @@
         </p:blipFill>
         <p:spPr>
           <a:xfrm>
-            <a:off x="1913116" y="808996"/>
+            <a:off x="1973797" y="808996"/>
             <a:ext cx="1047575" cy="2455775"/>
           </a:xfrm>
           <a:prstGeom prst="rect">
@@ -3150,7 +3150,7 @@
         </p:blipFill>
         <p:spPr>
           <a:xfrm>
-            <a:off x="3176005" y="808995"/>
+            <a:off x="3229732" y="808995"/>
             <a:ext cx="586360" cy="2455777"/>
           </a:xfrm>
           <a:prstGeom prst="rect">
@@ -3179,7 +3179,7 @@
         </p:blipFill>
         <p:spPr>
           <a:xfrm flipH="1">
-            <a:off x="6392537" y="808997"/>
+            <a:off x="6423410" y="808997"/>
             <a:ext cx="329507" cy="2449425"/>
           </a:xfrm>
           <a:prstGeom prst="rect">
@@ -3208,7 +3208,7 @@
         </p:blipFill>
         <p:spPr>
           <a:xfrm>
-            <a:off x="7237561" y="808996"/>
+            <a:off x="7330835" y="808996"/>
             <a:ext cx="639075" cy="2449426"/>
           </a:xfrm>
           <a:prstGeom prst="rect">
@@ -3237,7 +3237,7 @@
         </p:blipFill>
         <p:spPr>
           <a:xfrm>
-            <a:off x="5138978" y="4705513"/>
+            <a:off x="5183207" y="4705513"/>
             <a:ext cx="802872" cy="2455774"/>
           </a:xfrm>
           <a:prstGeom prst="rect">
@@ -3266,7 +3266,7 @@
         </p:blipFill>
         <p:spPr>
           <a:xfrm>
-            <a:off x="6321029" y="4705515"/>
+            <a:off x="6347706" y="4705515"/>
             <a:ext cx="492769" cy="2449423"/>
           </a:xfrm>
           <a:prstGeom prst="rect">
@@ -3314,7 +3314,7 @@
         </p:blipFill>
         <p:spPr>
           <a:xfrm>
-            <a:off x="2973869" y="4705513"/>
+            <a:off x="3038194" y="4705513"/>
             <a:ext cx="964162" cy="2452747"/>
           </a:xfrm>
           <a:prstGeom prst="rect">
@@ -3388,7 +3388,7 @@
         </p:blipFill>
         <p:spPr>
           <a:xfrm>
-            <a:off x="2019981" y="846948"/>
+            <a:off x="2080662" y="846948"/>
             <a:ext cx="232852" cy="232852"/>
           </a:xfrm>
           <a:prstGeom prst="rect">
@@ -3424,7 +3424,7 @@
         </p:blipFill>
         <p:spPr>
           <a:xfrm>
-            <a:off x="3028528" y="4737535"/>
+            <a:off x="3092853" y="4737535"/>
             <a:ext cx="232852" cy="232852"/>
           </a:xfrm>
           <a:prstGeom prst="rect">
@@ -3460,7 +3460,7 @@
         </p:blipFill>
         <p:spPr>
           <a:xfrm>
-            <a:off x="5160810" y="4726188"/>
+            <a:off x="5205039" y="4726188"/>
             <a:ext cx="232852" cy="232852"/>
           </a:xfrm>
           <a:prstGeom prst="rect">
@@ -3496,7 +3496,7 @@
         </p:blipFill>
         <p:spPr>
           <a:xfrm>
-            <a:off x="6126435" y="846017"/>
+            <a:off x="6157308" y="846017"/>
             <a:ext cx="233783" cy="233783"/>
           </a:xfrm>
           <a:prstGeom prst="rect">
@@ -3532,7 +3532,7 @@
         </p:blipFill>
         <p:spPr>
           <a:xfrm>
-            <a:off x="7120669" y="829672"/>
+            <a:off x="7213943" y="829672"/>
             <a:ext cx="233783" cy="233783"/>
           </a:xfrm>
           <a:prstGeom prst="rect">
@@ -3568,7 +3568,7 @@
         </p:blipFill>
         <p:spPr>
           <a:xfrm>
-            <a:off x="6087246" y="4719839"/>
+            <a:off x="6113923" y="4719839"/>
             <a:ext cx="233783" cy="233783"/>
           </a:xfrm>
           <a:prstGeom prst="rect">
@@ -3604,7 +3604,7 @@
         </p:blipFill>
         <p:spPr>
           <a:xfrm>
-            <a:off x="3049443" y="829672"/>
+            <a:off x="3103170" y="829672"/>
             <a:ext cx="232852" cy="232852"/>
           </a:xfrm>
           <a:prstGeom prst="rect">
@@ -3640,7 +3640,7 @@
         </p:blipFill>
         <p:spPr>
           <a:xfrm>
-            <a:off x="7216223" y="4737535"/>
+            <a:off x="7282138" y="4737535"/>
             <a:ext cx="233783" cy="233783"/>
           </a:xfrm>
           <a:prstGeom prst="rect">
@@ -3676,7 +3676,7 @@
         </p:blipFill>
         <p:spPr>
           <a:xfrm>
-            <a:off x="4084656" y="4732329"/>
+            <a:off x="4145149" y="4732329"/>
             <a:ext cx="233783" cy="233783"/>
           </a:xfrm>
           <a:prstGeom prst="rect">
@@ -3712,7 +3712,7 @@
         </p:blipFill>
         <p:spPr>
           <a:xfrm>
-            <a:off x="2024633" y="4732328"/>
+            <a:off x="2135646" y="4732328"/>
             <a:ext cx="233783" cy="233783"/>
           </a:xfrm>
           <a:prstGeom prst="rect">
@@ -3741,7 +3741,7 @@
         </p:blipFill>
         <p:spPr>
           <a:xfrm>
-            <a:off x="4190279" y="815348"/>
+            <a:off x="4251857" y="815348"/>
             <a:ext cx="595452" cy="2452745"/>
           </a:xfrm>
           <a:prstGeom prst="rect">
@@ -3777,7 +3777,7 @@
         </p:blipFill>
         <p:spPr>
           <a:xfrm>
-            <a:off x="4073853" y="847368"/>
+            <a:off x="4135431" y="847368"/>
             <a:ext cx="232852" cy="232852"/>
           </a:xfrm>
           <a:prstGeom prst="rect">
@@ -3806,7 +3806,7 @@
         </p:blipFill>
         <p:spPr>
           <a:xfrm>
-            <a:off x="5272255" y="805675"/>
+            <a:off x="5344137" y="805675"/>
             <a:ext cx="455416" cy="2452747"/>
           </a:xfrm>
           <a:prstGeom prst="rect">
@@ -3842,7 +3842,7 @@
         </p:blipFill>
         <p:spPr>
           <a:xfrm>
-            <a:off x="5142703" y="839327"/>
+            <a:off x="5214585" y="839327"/>
             <a:ext cx="233783" cy="233783"/>
           </a:xfrm>
           <a:prstGeom prst="rect">
@@ -3879,7 +3879,7 @@
         </p:blipFill>
         <p:spPr bwMode="auto">
           <a:xfrm>
-            <a:off x="7439180" y="4723338"/>
+            <a:off x="7505095" y="4723338"/>
             <a:ext cx="287309" cy="2440858"/>
           </a:xfrm>
           <a:prstGeom prst="rect">

</xml_diff>